<commit_message>
Slide 2: live demo and GitHub links; README live link
Co-Authored-By: Claude Opus 5.5 <noreply@anthropic.com>
</commit_message>
<xml_diff>
--- a/deck/NidhiSetu_SIH26265_Idea.pptx
+++ b/deck/NidhiSetu_SIH26265_Idea.pptx
@@ -7215,11 +7215,12 @@
             <a:r>
               <a:rPr sz="1000" b="0" i="0" u="none">
                 <a:solidFill>
-                  <a:srgbClr val="5B6476"/>
-                </a:solidFill>
-                <a:latin typeface="Arial"/>
-              </a:rPr>
-              <a:t>[add link]</a:t>
+                  <a:srgbClr val="0070C0"/>
+                </a:solidFill>
+                <a:latin typeface="Arial"/>
+                <a:hlinkClick r:id="rId6"/>
+              </a:rPr>
+              <a:t>nidhisetu-l4et.onrender.com</a:t>
             </a:r>
             <a:r>
               <a:rPr sz="1000" b="1" i="0" u="none">
@@ -7233,11 +7234,12 @@
             <a:r>
               <a:rPr sz="1000" b="0" i="0" u="none">
                 <a:solidFill>
-                  <a:srgbClr val="5B6476"/>
-                </a:solidFill>
-                <a:latin typeface="Arial"/>
-              </a:rPr>
-              <a:t>[add GitHub link]</a:t>
+                  <a:srgbClr val="0070C0"/>
+                </a:solidFill>
+                <a:latin typeface="Arial"/>
+                <a:hlinkClick r:id="rId7"/>
+              </a:rPr>
+              <a:t>github.com/Amith-Codez/NidhiSetu</a:t>
             </a:r>
           </a:p>
         </p:txBody>

</xml_diff>